<commit_message>
Use official Alleanza Academy logo in deck and assets
- Replace reconstructed placeholder logo with the official artwork
- Auto-derive white-wordmark (dark backgrounds) and shield-only variants
- Make build scripts repo-relative and reproducible
- Update presentation README

Co-Authored-By: Claude Opus 4.8 <noreply@anthropic.com>
Claude-Session: https://claude.ai/code/session_01Eevi8xc23gcb927VYP4bZC
</commit_message>
<xml_diff>
--- a/presentation/Alleanza_Academy_Presentacion.pptx
+++ b/presentation/Alleanza_Academy_Presentacion.pptx
@@ -3166,7 +3166,7 @@
         <p:spPr>
           <a:xfrm>
             <a:off x="777240" y="1417320"/>
-            <a:ext cx="5760720" cy="2278966"/>
+            <a:ext cx="5760720" cy="1971192"/>
           </a:xfrm>
           <a:prstGeom prst="rect">
             <a:avLst/>
@@ -3425,8 +3425,8 @@
         </p:blipFill>
         <p:spPr>
           <a:xfrm>
-            <a:off x="10195560" y="384048"/>
-            <a:ext cx="1201928" cy="475488"/>
+            <a:off x="10406074" y="384048"/>
+            <a:ext cx="1282701" cy="438912"/>
           </a:xfrm>
           <a:prstGeom prst="rect">
             <a:avLst/>
@@ -4586,8 +4586,8 @@
         </p:blipFill>
         <p:spPr>
           <a:xfrm>
-            <a:off x="10195560" y="384048"/>
-            <a:ext cx="1201928" cy="475488"/>
+            <a:off x="10406074" y="384048"/>
+            <a:ext cx="1282701" cy="438912"/>
           </a:xfrm>
           <a:prstGeom prst="rect">
             <a:avLst/>
@@ -5424,8 +5424,8 @@
         </p:blipFill>
         <p:spPr>
           <a:xfrm>
-            <a:off x="10195560" y="384048"/>
-            <a:ext cx="1201928" cy="475488"/>
+            <a:off x="10406074" y="384048"/>
+            <a:ext cx="1282701" cy="438912"/>
           </a:xfrm>
           <a:prstGeom prst="rect">
             <a:avLst/>
@@ -6121,8 +6121,8 @@
         </p:blipFill>
         <p:spPr>
           <a:xfrm>
-            <a:off x="10195560" y="384048"/>
-            <a:ext cx="1201928" cy="475488"/>
+            <a:off x="10406074" y="384048"/>
+            <a:ext cx="1282701" cy="438912"/>
           </a:xfrm>
           <a:prstGeom prst="rect">
             <a:avLst/>
@@ -7144,8 +7144,8 @@
         </p:blipFill>
         <p:spPr>
           <a:xfrm>
-            <a:off x="10195560" y="384048"/>
-            <a:ext cx="1201928" cy="475488"/>
+            <a:off x="10406074" y="384048"/>
+            <a:ext cx="1282701" cy="438912"/>
           </a:xfrm>
           <a:prstGeom prst="rect">
             <a:avLst/>
@@ -7892,8 +7892,8 @@
         </p:blipFill>
         <p:spPr>
           <a:xfrm>
-            <a:off x="10195560" y="384048"/>
-            <a:ext cx="1201928" cy="475488"/>
+            <a:off x="10406074" y="384048"/>
+            <a:ext cx="1282701" cy="438912"/>
           </a:xfrm>
           <a:prstGeom prst="rect">
             <a:avLst/>
@@ -8614,8 +8614,8 @@
         </p:blipFill>
         <p:spPr>
           <a:xfrm>
-            <a:off x="10195560" y="384048"/>
-            <a:ext cx="1201928" cy="475488"/>
+            <a:off x="10406074" y="384048"/>
+            <a:ext cx="1282701" cy="438912"/>
           </a:xfrm>
           <a:prstGeom prst="rect">
             <a:avLst/>
@@ -9825,8 +9825,8 @@
         </p:blipFill>
         <p:spPr>
           <a:xfrm>
-            <a:off x="10195560" y="384048"/>
-            <a:ext cx="1201928" cy="475488"/>
+            <a:off x="10406074" y="384048"/>
+            <a:ext cx="1282701" cy="438912"/>
           </a:xfrm>
           <a:prstGeom prst="rect">
             <a:avLst/>
@@ -10663,8 +10663,8 @@
         </p:blipFill>
         <p:spPr>
           <a:xfrm>
-            <a:off x="10195560" y="384048"/>
-            <a:ext cx="1201928" cy="475488"/>
+            <a:off x="10406074" y="384048"/>
+            <a:ext cx="1282701" cy="438912"/>
           </a:xfrm>
           <a:prstGeom prst="rect">
             <a:avLst/>

</xml_diff>